<commit_message>
polish(content-gen): add verified standards bodies grounding (QED-C, NIST PQC, ISO 27001)
</commit_message>
<xml_diff>
--- a/output/Quantum_Computing_presentation.pptx
+++ b/output/Quantum_Computing_presentation.pptx
@@ -1229,7 +1229,7 @@
               </a:defRPr>
             </a:pPr>
             <a:r>
-              <a:t>Quantum Computing Strategic Overview</a:t>
+              <a:t>Quantum Computing: Strategic Overview</a:t>
             </a:r>
           </a:p>
         </p:txBody>
@@ -1418,7 +1418,7 @@
               </a:defRPr>
             </a:pPr>
             <a:r>
-              <a:t>CLASSICAL COMPUTING LIMITATIONS</a:t>
+              <a:t>CLASSICAL COMPUTING CHALLENGES</a:t>
             </a:r>
           </a:p>
         </p:txBody>
@@ -1454,7 +1454,7 @@
               </a:defRPr>
             </a:pPr>
             <a:r>
-              <a:t>Classical Computing Limitations and Quantum Challenges</a:t>
+              <a:t>Classical Computing Limitations and Quantum Opportunities</a:t>
             </a:r>
           </a:p>
         </p:txBody>
@@ -1512,7 +1512,7 @@
                 </a:solidFill>
                 <a:latin typeface="Calibri"/>
               </a:rPr>
-              <a:t>•  Computational Complexity: </a:t>
+              <a:t>•  Exponential Scaling Challenges: </a:t>
             </a:r>
             <a:r>
               <a:rPr sz="1150" b="0">
@@ -1521,7 +1521,7 @@
                 </a:solidFill>
                 <a:latin typeface="Calibri"/>
               </a:rPr>
-              <a:t>Classical computers face exponential scaling challenges due to the curse of dimensionality.</a:t>
+              <a:t>Classical systems face exponential scaling challenges due to the exponential growth of computational complexity.</a:t>
             </a:r>
           </a:p>
           <a:p>
@@ -1537,7 +1537,7 @@
                 </a:solidFill>
                 <a:latin typeface="Calibri"/>
               </a:rPr>
-              <a:t>•  Environmental Decoherence: </a:t>
+              <a:t>•  Noise and Decoherence: </a:t>
             </a:r>
             <a:r>
               <a:rPr sz="1150" b="0">
@@ -1546,7 +1546,7 @@
                 </a:solidFill>
                 <a:latin typeface="Calibri"/>
               </a:rPr>
-              <a:t>Quantum systems are prone to decoherence caused by environmental noise and interactions.</a:t>
+              <a:t>Classical systems are prone to noise and decoherence, leading to errors and reduced computational accuracy.</a:t>
             </a:r>
           </a:p>
           <a:p>
@@ -1562,7 +1562,7 @@
                 </a:solidFill>
                 <a:latin typeface="Calibri"/>
               </a:rPr>
-              <a:t>•  Physical Constraints: </a:t>
+              <a:t>•  Quantum Computing as a Solution: </a:t>
             </a:r>
             <a:r>
               <a:rPr sz="1150" b="0">
@@ -1571,7 +1571,7 @@
                 </a:solidFill>
                 <a:latin typeface="Calibri"/>
               </a:rPr>
-              <a:t>Classical computers are limited by physical constraints such as power consumption and heat dissipation.</a:t>
+              <a:t>Quantum computing offers a solution to these challenges through the use of qubits and quantum gates.</a:t>
             </a:r>
           </a:p>
           <a:p>
@@ -1587,7 +1587,7 @@
                 </a:solidFill>
                 <a:latin typeface="Calibri"/>
               </a:rPr>
-              <a:t>•  Quantum Challenges: </a:t>
+              <a:t>•  Quantum Advantage: </a:t>
             </a:r>
             <a:r>
               <a:rPr sz="1150" b="0">
@@ -1596,7 +1596,7 @@
                 </a:solidFill>
                 <a:latin typeface="Calibri"/>
               </a:rPr>
-              <a:t>Quantum computing introduces new challenges such as quantum noise, error correction, and control.</a:t>
+              <a:t>Quantum computing can provide a significant advantage over classical computing for certain problems, such as factoring large numbers.</a:t>
             </a:r>
           </a:p>
         </p:txBody>
@@ -1651,7 +1651,7 @@
               </a:defRPr>
             </a:pPr>
             <a:r>
-              <a:t>KEY TAKEAWAY: Classical computing faces significant limitations in scalability, noise, and physical constraints, which quantum computing aims to address.</a:t>
+              <a:t>KEY TAKEAWAY: Classical computing has limitations that quantum computing can address.</a:t>
             </a:r>
           </a:p>
         </p:txBody>
@@ -1808,7 +1808,7 @@
                 </a:solidFill>
                 <a:latin typeface="Calibri"/>
               </a:rPr>
-              <a:t>Superconducting circuits use Josephson junctions to create qubits with high coherence times.</a:t>
+              <a:t>Superconducting circuits are a common implementation of qubits, using Josephson junctions to create a superconducting loop.</a:t>
             </a:r>
           </a:p>
           <a:p>
@@ -1824,7 +1824,7 @@
                 </a:solidFill>
                 <a:latin typeface="Calibri"/>
               </a:rPr>
-              <a:t>•  Trapped Ion Modalities: </a:t>
+              <a:t>•  Trapped Ion Architectures: </a:t>
             </a:r>
             <a:r>
               <a:rPr sz="1150" b="0">
@@ -1833,7 +1833,7 @@
                 </a:solidFill>
                 <a:latin typeface="Calibri"/>
               </a:rPr>
-              <a:t>Trapped ions use electromagnetic fields to control and manipulate qubits with high precision.</a:t>
+              <a:t>Trapped ion architectures use ions trapped in electromagnetic fields to create a qubit.</a:t>
             </a:r>
           </a:p>
           <a:p>
@@ -1858,7 +1858,7 @@
                 </a:solidFill>
                 <a:latin typeface="Calibri"/>
               </a:rPr>
-              <a:t>Quantum dots use semiconductor materials to create qubits with high coherence times and low noise.</a:t>
+              <a:t>Quantum dot implementations use semiconductor nanocrystals to create a qubit.</a:t>
             </a:r>
           </a:p>
           <a:p>
@@ -1874,7 +1874,7 @@
                 </a:solidFill>
                 <a:latin typeface="Calibri"/>
               </a:rPr>
-              <a:t>•  Topological Qubit Implementations: </a:t>
+              <a:t>•  Topological Quantum Computing: </a:t>
             </a:r>
             <a:r>
               <a:rPr sz="1150" b="0">
@@ -1883,7 +1883,7 @@
                 </a:solidFill>
                 <a:latin typeface="Calibri"/>
               </a:rPr>
-              <a:t>Topological qubits use exotic materials to create qubits with high coherence times and robustness against noise.</a:t>
+              <a:t>Topological quantum computing uses exotic materials to create a qubit that is resistant to decoherence.</a:t>
             </a:r>
           </a:p>
         </p:txBody>
@@ -1938,7 +1938,7 @@
               </a:defRPr>
             </a:pPr>
             <a:r>
-              <a:t>KEY TAKEAWAY: Quantum hardware architectures and qubit implementations vary in their approach to coherence, noise, and control.</a:t>
+              <a:t>KEY TAKEAWAY: There are various hardware architectures and qubit implementations in quantum computing.</a:t>
             </a:r>
           </a:p>
         </p:txBody>
@@ -2086,7 +2086,7 @@
                 </a:solidFill>
                 <a:latin typeface="Calibri"/>
               </a:rPr>
-              <a:t>•  Shor's Factoring Algorithm: </a:t>
+              <a:t>•  Shor's Algorithm: </a:t>
             </a:r>
             <a:r>
               <a:rPr sz="1150" b="0">
@@ -2095,7 +2095,7 @@
                 </a:solidFill>
                 <a:latin typeface="Calibri"/>
               </a:rPr>
-              <a:t>Shor's algorithm uses quantum parallelism to factor large numbers exponentially faster than classical algorithms.</a:t>
+              <a:t>Shor's algorithm is a quantum algorithm for factoring large numbers exponentially faster than classical algorithms.</a:t>
             </a:r>
           </a:p>
           <a:p>
@@ -2111,7 +2111,7 @@
                 </a:solidFill>
                 <a:latin typeface="Calibri"/>
               </a:rPr>
-              <a:t>•  Grover's Database Search Algorithm: </a:t>
+              <a:t>•  Grover's Algorithm: </a:t>
             </a:r>
             <a:r>
               <a:rPr sz="1150" b="0">
@@ -2120,7 +2120,7 @@
                 </a:solidFill>
                 <a:latin typeface="Calibri"/>
               </a:rPr>
-              <a:t>Grover's algorithm uses quantum parallelism to search unsorted databases exponentially faster than classical algorithms.</a:t>
+              <a:t>Grover's algorithm is a quantum algorithm for searching an unsorted database exponentially faster than classical algorithms.</a:t>
             </a:r>
           </a:p>
           <a:p>
@@ -2136,7 +2136,7 @@
                 </a:solidFill>
                 <a:latin typeface="Calibri"/>
               </a:rPr>
-              <a:t>•  Quantum Simulation and Optimization Algorithms: </a:t>
+              <a:t>•  Quantum Simulation: </a:t>
             </a:r>
             <a:r>
               <a:rPr sz="1150" b="0">
@@ -2145,7 +2145,7 @@
                 </a:solidFill>
                 <a:latin typeface="Calibri"/>
               </a:rPr>
-              <a:t>Quantum simulation and optimization algorithms use quantum parallelism to solve complex problems in fields such as chemistry and materials science.</a:t>
+              <a:t>Quantum simulation is a quantum algorithm for simulating complex quantum systems exponentially faster than classical algorithms.</a:t>
             </a:r>
           </a:p>
           <a:p>
@@ -2161,7 +2161,7 @@
                 </a:solidFill>
                 <a:latin typeface="Calibri"/>
               </a:rPr>
-              <a:t>•  Quantum Machine Learning Algorithms: </a:t>
+              <a:t>•  Quantum Optimization: </a:t>
             </a:r>
             <a:r>
               <a:rPr sz="1150" b="0">
@@ -2170,7 +2170,7 @@
                 </a:solidFill>
                 <a:latin typeface="Calibri"/>
               </a:rPr>
-              <a:t>Quantum machine learning algorithms use quantum parallelism to speed up machine learning tasks such as clustering and classification.</a:t>
+              <a:t>Quantum optimization is a quantum algorithm for solving complex optimization problems exponentially faster than classical algorithms.</a:t>
             </a:r>
           </a:p>
         </p:txBody>
@@ -2225,7 +2225,7 @@
               </a:defRPr>
             </a:pPr>
             <a:r>
-              <a:t>KEY TAKEAWAY: Quantum algorithms offer significant speedups over classical algorithms in specific domains, but require careful implementation and optimization.</a:t>
+              <a:t>KEY TAKEAWAY: Quantum algorithms can provide significant speedups over classical algorithms for certain problems.</a:t>
             </a:r>
           </a:p>
         </p:txBody>
@@ -2382,7 +2382,7 @@
                 </a:solidFill>
                 <a:latin typeface="Calibri"/>
               </a:rPr>
-              <a:t>Surface codes use a 2D lattice of qubits to detect and correct errors with high fidelity.</a:t>
+              <a:t>Surface code topologies are a method of error correction in quantum computing, using a lattice of qubits to detect and correct errors.</a:t>
             </a:r>
           </a:p>
           <a:p>
@@ -2398,7 +2398,7 @@
                 </a:solidFill>
                 <a:latin typeface="Calibri"/>
               </a:rPr>
-              <a:t>•  Error Thresholds and Physical-to-Logical Qubit Mapping: </a:t>
+              <a:t>•  Physical-to-Logical Qubit Overhead: </a:t>
             </a:r>
             <a:r>
               <a:rPr sz="1150" b="0">
@@ -2407,7 +2407,7 @@
                 </a:solidFill>
                 <a:latin typeface="Calibri"/>
               </a:rPr>
-              <a:t>Error thresholds determine the maximum error rate tolerated by a quantum computer, while physical-to-logical qubit mapping optimizes resource usage.</a:t>
+              <a:t>Physical-to-logical qubit overhead is a measure of the number of physical qubits required to implement a logical qubit.</a:t>
             </a:r>
           </a:p>
           <a:p>
@@ -2423,7 +2423,7 @@
                 </a:solidFill>
                 <a:latin typeface="Calibri"/>
               </a:rPr>
-              <a:t>•  Quantum Error Correction Codes and Techniques: </a:t>
+              <a:t>•  Error Thresholds: </a:t>
             </a:r>
             <a:r>
               <a:rPr sz="1150" b="0">
@@ -2432,7 +2432,7 @@
                 </a:solidFill>
                 <a:latin typeface="Calibri"/>
               </a:rPr>
-              <a:t>Quantum error correction codes and techniques such as Steane's code and concatenated codes mitigate the effects of noise and errors.</a:t>
+              <a:t>Error thresholds are a measure of the maximum error rate that can be tolerated in a quantum computer before it becomes unreliable.</a:t>
             </a:r>
           </a:p>
           <a:p>
@@ -2448,7 +2448,7 @@
                 </a:solidFill>
                 <a:latin typeface="Calibri"/>
               </a:rPr>
-              <a:t>•  Fault-Tolerant Quantum Computing Architectures: </a:t>
+              <a:t>•  Quantum Error Correction Codes: </a:t>
             </a:r>
             <a:r>
               <a:rPr sz="1150" b="0">
@@ -2457,7 +2457,7 @@
                 </a:solidFill>
                 <a:latin typeface="Calibri"/>
               </a:rPr>
-              <a:t>Fault-tolerant quantum computing architectures such as the surface code and topological code enable reliable and scalable quantum computing.</a:t>
+              <a:t>Quantum error correction codes are a method of correcting errors in quantum computing, using redundant information to detect and correct errors.</a:t>
             </a:r>
           </a:p>
         </p:txBody>
@@ -2512,7 +2512,7 @@
               </a:defRPr>
             </a:pPr>
             <a:r>
-              <a:t>KEY TAKEAWAY: Fault-tolerant quantum computing and error correction are essential for reliable and scalable quantum computing, but require careful design and implementation.</a:t>
+              <a:t>KEY TAKEAWAY: Fault-tolerant quantum computing requires robust error correction mechanisms.</a:t>
             </a:r>
           </a:p>
         </p:txBody>
@@ -2660,7 +2660,7 @@
                 </a:solidFill>
                 <a:latin typeface="Calibri"/>
               </a:rPr>
-              <a:t>•  Post-Quantum Cryptography and Secure Communication: </a:t>
+              <a:t>•  Post-Quantum Cryptography: </a:t>
             </a:r>
             <a:r>
               <a:rPr sz="1150" b="0">
@@ -2669,7 +2669,7 @@
                 </a:solidFill>
                 <a:latin typeface="Calibri"/>
               </a:rPr>
-              <a:t>Post-quantum cryptography uses quantum-resistant algorithms to secure communication in the face of quantum computing threats.</a:t>
+              <a:t>Post-quantum cryptography is a method of secure communication that is resistant to quantum attacks.</a:t>
             </a:r>
           </a:p>
           <a:p>
@@ -2685,7 +2685,7 @@
                 </a:solidFill>
                 <a:latin typeface="Calibri"/>
               </a:rPr>
-              <a:t>•  Financial Portfolio Optimization and Risk Analysis: </a:t>
+              <a:t>•  Financial Portfolio Optimization: </a:t>
             </a:r>
             <a:r>
               <a:rPr sz="1150" b="0">
@@ -2694,7 +2694,7 @@
                 </a:solidFill>
                 <a:latin typeface="Calibri"/>
               </a:rPr>
-              <a:t>Quantum computing optimizes financial portfolios and analyzes risk using complex simulations and machine learning algorithms.</a:t>
+              <a:t>Financial portfolio optimization is a method of optimizing investment portfolios using quantum computing.</a:t>
             </a:r>
           </a:p>
           <a:p>
@@ -2710,7 +2710,7 @@
                 </a:solidFill>
                 <a:latin typeface="Calibri"/>
               </a:rPr>
-              <a:t>•  Material Simulation and Chemical Discovery: </a:t>
+              <a:t>•  Materials Science Simulation: </a:t>
             </a:r>
             <a:r>
               <a:rPr sz="1150" b="0">
@@ -2719,7 +2719,7 @@
                 </a:solidFill>
                 <a:latin typeface="Calibri"/>
               </a:rPr>
-              <a:t>Quantum computing simulates material properties and discovers new materials using quantum algorithms and machine learning techniques.</a:t>
+              <a:t>Materials science simulation is a method of simulating the properties of materials using quantum computing.</a:t>
             </a:r>
           </a:p>
           <a:p>
@@ -2735,7 +2735,7 @@
                 </a:solidFill>
                 <a:latin typeface="Calibri"/>
               </a:rPr>
-              <a:t>•  Supply Chain Optimization and Logistics: </a:t>
+              <a:t>•  Logistics Optimization: </a:t>
             </a:r>
             <a:r>
               <a:rPr sz="1150" b="0">
@@ -2744,7 +2744,7 @@
                 </a:solidFill>
                 <a:latin typeface="Calibri"/>
               </a:rPr>
-              <a:t>Quantum computing optimizes supply chains and logistics using complex simulations and machine learning algorithms.</a:t>
+              <a:t>Logistics optimization is a method of optimizing supply chain management using quantum computing.</a:t>
             </a:r>
           </a:p>
         </p:txBody>
@@ -2799,7 +2799,7 @@
               </a:defRPr>
             </a:pPr>
             <a:r>
-              <a:t>KEY TAKEAWAY: Quantum computing has significant practical applications in enterprise domains such as cryptography, finance, materials science, and logistics.</a:t>
+              <a:t>KEY TAKEAWAY: Quantum computing has practical applications in various industries.</a:t>
             </a:r>
           </a:p>
         </p:txBody>
@@ -2889,7 +2889,7 @@
               </a:defRPr>
             </a:pPr>
             <a:r>
-              <a:t>Operational Benchmarks, Quantum Volume Metrics, and Hardware Roadmap</a:t>
+              <a:t>Operational Benchmarks and Quantum Volume Metrics</a:t>
             </a:r>
           </a:p>
         </p:txBody>
@@ -2947,7 +2947,7 @@
                 </a:solidFill>
                 <a:latin typeface="Calibri"/>
               </a:rPr>
-              <a:t>•  Quantum Volume and Benchmarking Metrics: </a:t>
+              <a:t>•  Quantum Volume: </a:t>
             </a:r>
             <a:r>
               <a:rPr sz="1150" b="0">
@@ -2956,7 +2956,7 @@
                 </a:solidFill>
                 <a:latin typeface="Calibri"/>
               </a:rPr>
-              <a:t>Quantum volume and benchmarking metrics such as the IBM Quantum Volume and the Google Quantum Volume measure the performance and scalability of quantum computers.</a:t>
+              <a:t>Quantum volume is a measure of the computational power of a quantum computer, using the number of qubits and the number of cycles.</a:t>
             </a:r>
           </a:p>
           <a:p>
@@ -2972,7 +2972,7 @@
                 </a:solidFill>
                 <a:latin typeface="Calibri"/>
               </a:rPr>
-              <a:t>•  Hardware Roadmap and Development Timelines: </a:t>
+              <a:t>•  Operational Benchmarks: </a:t>
             </a:r>
             <a:r>
               <a:rPr sz="1150" b="0">
@@ -2981,7 +2981,7 @@
                 </a:solidFill>
                 <a:latin typeface="Calibri"/>
               </a:rPr>
-              <a:t>Hardware roadmaps and development timelines outline the progress and milestones of quantum computing hardware development.</a:t>
+              <a:t>Operational benchmarks are a measure of the performance of a quantum computer, using metrics such as error rates and fidelity.</a:t>
             </a:r>
           </a:p>
           <a:p>
@@ -2997,7 +2997,7 @@
                 </a:solidFill>
                 <a:latin typeface="Calibri"/>
               </a:rPr>
-              <a:t>•  Operational Performance and Reliability Metrics: </a:t>
+              <a:t>•  Hardware Roadmap: </a:t>
             </a:r>
             <a:r>
               <a:rPr sz="1150" b="0">
@@ -3006,7 +3006,7 @@
                 </a:solidFill>
                 <a:latin typeface="Calibri"/>
               </a:rPr>
-              <a:t>Operational performance and reliability metrics such as qubit coherence times and error rates measure the reliability and performance of quantum computers.</a:t>
+              <a:t>The hardware roadmap is a plan for the development and deployment of quantum computers, including timelines and milestones.</a:t>
             </a:r>
           </a:p>
           <a:p>
@@ -3022,7 +3022,7 @@
                 </a:solidFill>
                 <a:latin typeface="Calibri"/>
               </a:rPr>
-              <a:t>•  Quantum Computing Industry Standards and Certifications: </a:t>
+              <a:t>•  Performance Metrics: </a:t>
             </a:r>
             <a:r>
               <a:rPr sz="1150" b="0">
@@ -3031,7 +3031,7 @@
                 </a:solidFill>
                 <a:latin typeface="Calibri"/>
               </a:rPr>
-              <a:t>Quantum computing industry standards and certifications such as the Quantum Computing Industry Consortium (QCIC) and the International Organization for Standardization (ISO) establish best practices and guidelines for quantum computing.</a:t>
+              <a:t>Performance metrics are a measure of the performance of a quantum computer, using metrics such as quantum volume and operational benchmarks.</a:t>
             </a:r>
           </a:p>
         </p:txBody>
@@ -3086,7 +3086,7 @@
               </a:defRPr>
             </a:pPr>
             <a:r>
-              <a:t>KEY TAKEAWAY: Quantum computing benchmarks, metrics, and industry standards provide a framework for evaluating and comparing quantum computing performance and reliability.</a:t>
+              <a:t>KEY TAKEAWAY: Quantum computing has operational benchmarks and metrics to measure its performance.</a:t>
             </a:r>
           </a:p>
         </p:txBody>
@@ -3176,7 +3176,7 @@
               </a:defRPr>
             </a:pPr>
             <a:r>
-              <a:t>Strategic Recommendations, Governance, and Enterprise Action Plan</a:t>
+              <a:t>Strategic Recommendations and Enterprise Action Plan</a:t>
             </a:r>
           </a:p>
         </p:txBody>
@@ -3234,7 +3234,7 @@
                 </a:solidFill>
                 <a:latin typeface="Calibri"/>
               </a:rPr>
-              <a:t>•  Quantum Computing Strategy and Roadmap: </a:t>
+              <a:t>•  Quantum Computing Governance: </a:t>
             </a:r>
             <a:r>
               <a:rPr sz="1150" b="0">
@@ -3243,7 +3243,7 @@
                 </a:solidFill>
                 <a:latin typeface="Calibri"/>
               </a:rPr>
-              <a:t>A quantum computing strategy and roadmap outlines the goals, objectives, and milestones of a quantum computing initiative.</a:t>
+              <a:t>Quantum computing governance is a framework for managing the development and deployment of quantum computers, including risk management and security.</a:t>
             </a:r>
           </a:p>
           <a:p>
@@ -3259,7 +3259,7 @@
                 </a:solidFill>
                 <a:latin typeface="Calibri"/>
               </a:rPr>
-              <a:t>•  Governance and Risk Management Frameworks: </a:t>
+              <a:t>•  Immediate Action Plan: </a:t>
             </a:r>
             <a:r>
               <a:rPr sz="1150" b="0">
@@ -3268,7 +3268,7 @@
                 </a:solidFill>
                 <a:latin typeface="Calibri"/>
               </a:rPr>
-              <a:t>Governance and risk management frameworks establish policies, procedures, and controls for quantum computing development and deployment.</a:t>
+              <a:t>The immediate action plan is a plan for the short-term development and deployment of quantum computers, including timelines and milestones.</a:t>
             </a:r>
           </a:p>
           <a:p>
@@ -3284,7 +3284,7 @@
                 </a:solidFill>
                 <a:latin typeface="Calibri"/>
               </a:rPr>
-              <a:t>•  Enterprise Action Plan and Implementation Roadmap: </a:t>
+              <a:t>•  Key Performance Indicators: </a:t>
             </a:r>
             <a:r>
               <a:rPr sz="1150" b="0">
@@ -3293,7 +3293,7 @@
                 </a:solidFill>
                 <a:latin typeface="Calibri"/>
               </a:rPr>
-              <a:t>An enterprise action plan and implementation roadmap outlines the steps and timelines for implementing quantum computing solutions and services.</a:t>
+              <a:t>Key performance indicators are a measure of the performance of a quantum computer, using metrics such as quantum volume and operational benchmarks.</a:t>
             </a:r>
           </a:p>
           <a:p>
@@ -3309,7 +3309,7 @@
                 </a:solidFill>
                 <a:latin typeface="Calibri"/>
               </a:rPr>
-              <a:t>•  Quantum Computing Talent Acquisition and Training: </a:t>
+              <a:t>•  Risk Management: </a:t>
             </a:r>
             <a:r>
               <a:rPr sz="1150" b="0">
@@ -3318,7 +3318,7 @@
                 </a:solidFill>
                 <a:latin typeface="Calibri"/>
               </a:rPr>
-              <a:t>Quantum computing talent acquisition and training programs develop the skills and expertise needed for quantum computing development and deployment.</a:t>
+              <a:t>Risk management is a framework for managing the risks associated with quantum computing, including security and regulatory risks.</a:t>
             </a:r>
           </a:p>
         </p:txBody>
@@ -3373,7 +3373,7 @@
               </a:defRPr>
             </a:pPr>
             <a:r>
-              <a:t>KEY TAKEAWAY: A well-planned quantum computing strategy, governance framework, and action plan are essential for successful quantum computing adoption and deployment.</a:t>
+              <a:t>KEY TAKEAWAY: A strategic plan is necessary for the development and deployment of quantum computers.</a:t>
             </a:r>
           </a:p>
         </p:txBody>

</xml_diff>

<commit_message>
feat: add tautology detector, contrastive few-shot prompts, and document iteration 3 in README
</commit_message>
<xml_diff>
--- a/output/Quantum_Computing_presentation.pptx
+++ b/output/Quantum_Computing_presentation.pptx
@@ -1229,7 +1229,7 @@
               </a:defRPr>
             </a:pPr>
             <a:r>
-              <a:t>Quantum Computing: Strategic Overview</a:t>
+              <a:t>Quantum Computing Strategic Overview</a:t>
             </a:r>
           </a:p>
         </p:txBody>
@@ -1418,7 +1418,7 @@
               </a:defRPr>
             </a:pPr>
             <a:r>
-              <a:t>CLASSICAL COMPUTING CHALLENGES</a:t>
+              <a:t>CLASSICAL COMPUTING CONSTRAINTS</a:t>
             </a:r>
           </a:p>
         </p:txBody>
@@ -1446,7 +1446,7 @@
           <a:lstStyle/>
           <a:p>
             <a:pPr algn="l">
-              <a:defRPr sz="1800" b="1">
+              <a:defRPr sz="2200" b="1">
                 <a:solidFill>
                   <a:srgbClr val="0B4F6C"/>
                 </a:solidFill>
@@ -1454,7 +1454,7 @@
               </a:defRPr>
             </a:pPr>
             <a:r>
-              <a:t>Classical Computing Limitations and Quantum Opportunities</a:t>
+              <a:t>Classical Computing Limitations</a:t>
             </a:r>
           </a:p>
         </p:txBody>
@@ -1467,8 +1467,8 @@
         </p:nvSpPr>
         <p:spPr>
           <a:xfrm>
-            <a:off x="731520" y="1353312"/>
-            <a:ext cx="7680960" cy="2395728"/>
+            <a:off x="731520" y="1234440"/>
+            <a:ext cx="7680960" cy="2514600"/>
           </a:xfrm>
           <a:prstGeom prst="roundRect">
             <a:avLst/>
@@ -1502,101 +1502,76 @@
           <a:p>
             <a:pPr algn="l">
               <a:spcAft>
-                <a:spcPts val="450"/>
+                <a:spcPts val="700"/>
               </a:spcAft>
             </a:pPr>
             <a:r>
-              <a:rPr sz="1150" b="1">
+              <a:rPr sz="1300" b="1">
                 <a:solidFill>
                   <a:srgbClr val="0B4F6C"/>
                 </a:solidFill>
                 <a:latin typeface="Calibri"/>
               </a:rPr>
-              <a:t>•  Exponential Scaling Challenges: </a:t>
-            </a:r>
-            <a:r>
-              <a:rPr sz="1150" b="0">
+              <a:t>•  Moore's Law Constraints: </a:t>
+            </a:r>
+            <a:r>
+              <a:rPr sz="1300" b="0">
                 <a:solidFill>
                   <a:srgbClr val="1F2937"/>
                 </a:solidFill>
                 <a:latin typeface="Calibri"/>
               </a:rPr>
-              <a:t>Classical systems face exponential scaling challenges due to the exponential growth of computational complexity.</a:t>
+              <a:t>Transistor density and clock speed scaling limits reached.</a:t>
             </a:r>
           </a:p>
           <a:p>
             <a:pPr algn="l">
               <a:spcAft>
-                <a:spcPts val="450"/>
+                <a:spcPts val="700"/>
               </a:spcAft>
             </a:pPr>
             <a:r>
-              <a:rPr sz="1150" b="1">
+              <a:rPr sz="1300" b="1">
                 <a:solidFill>
                   <a:srgbClr val="0B4F6C"/>
                 </a:solidFill>
                 <a:latin typeface="Calibri"/>
               </a:rPr>
-              <a:t>•  Noise and Decoherence: </a:t>
-            </a:r>
-            <a:r>
-              <a:rPr sz="1150" b="0">
+              <a:t>•  Quantum Noise and Decoherence: </a:t>
+            </a:r>
+            <a:r>
+              <a:rPr sz="1300" b="0">
                 <a:solidFill>
                   <a:srgbClr val="1F2937"/>
                 </a:solidFill>
                 <a:latin typeface="Calibri"/>
               </a:rPr>
-              <a:t>Classical systems are prone to noise and decoherence, leading to errors and reduced computational accuracy.</a:t>
+              <a:t>Uncontrolled physical interactions disrupt quantum states.</a:t>
             </a:r>
           </a:p>
           <a:p>
             <a:pPr algn="l">
               <a:spcAft>
-                <a:spcPts val="450"/>
+                <a:spcPts val="700"/>
               </a:spcAft>
             </a:pPr>
             <a:r>
-              <a:rPr sz="1150" b="1">
+              <a:rPr sz="1300" b="1">
                 <a:solidFill>
                   <a:srgbClr val="0B4F6C"/>
                 </a:solidFill>
                 <a:latin typeface="Calibri"/>
               </a:rPr>
-              <a:t>•  Quantum Computing as a Solution: </a:t>
-            </a:r>
-            <a:r>
-              <a:rPr sz="1150" b="0">
+              <a:t>•  Physical Challenges in Scaling: </a:t>
+            </a:r>
+            <a:r>
+              <a:rPr sz="1300" b="0">
                 <a:solidFill>
                   <a:srgbClr val="1F2937"/>
                 </a:solidFill>
                 <a:latin typeface="Calibri"/>
               </a:rPr>
-              <a:t>Quantum computing offers a solution to these challenges through the use of qubits and quantum gates.</a:t>
-            </a:r>
-          </a:p>
-          <a:p>
-            <a:pPr algn="l">
-              <a:spcAft>
-                <a:spcPts val="450"/>
-              </a:spcAft>
-            </a:pPr>
-            <a:r>
-              <a:rPr sz="1150" b="1">
-                <a:solidFill>
-                  <a:srgbClr val="0B4F6C"/>
-                </a:solidFill>
-                <a:latin typeface="Calibri"/>
-              </a:rPr>
-              <a:t>•  Quantum Advantage: </a:t>
-            </a:r>
-            <a:r>
-              <a:rPr sz="1150" b="0">
-                <a:solidFill>
-                  <a:srgbClr val="1F2937"/>
-                </a:solidFill>
-                <a:latin typeface="Calibri"/>
-              </a:rPr>
-              <a:t>Quantum computing can provide a significant advantage over classical computing for certain problems, such as factoring large numbers.</a:t>
+              <a:t>Heat dissipation, power consumption, and material limitations.</a:t>
             </a:r>
           </a:p>
         </p:txBody>
@@ -1651,7 +1626,7 @@
               </a:defRPr>
             </a:pPr>
             <a:r>
-              <a:t>KEY TAKEAWAY: Classical computing has limitations that quantum computing can address.</a:t>
+              <a:t>KEY TAKEAWAY: Classical computing faces fundamental scaling and noise limitations.</a:t>
             </a:r>
           </a:p>
         </p:txBody>
@@ -1733,7 +1708,7 @@
           <a:lstStyle/>
           <a:p>
             <a:pPr algn="l">
-              <a:defRPr sz="1800" b="1">
+              <a:defRPr sz="2200" b="1">
                 <a:solidFill>
                   <a:srgbClr val="0B4F6C"/>
                 </a:solidFill>
@@ -1741,7 +1716,7 @@
               </a:defRPr>
             </a:pPr>
             <a:r>
-              <a:t>Quantum Hardware Architectures and Qubit Implementations</a:t>
+              <a:t>Quantum Hardware Architectures</a:t>
             </a:r>
           </a:p>
         </p:txBody>
@@ -1754,8 +1729,8 @@
         </p:nvSpPr>
         <p:spPr>
           <a:xfrm>
-            <a:off x="731520" y="1353312"/>
-            <a:ext cx="7680960" cy="2395728"/>
+            <a:off x="731520" y="1234440"/>
+            <a:ext cx="7680960" cy="2514600"/>
           </a:xfrm>
           <a:prstGeom prst="roundRect">
             <a:avLst/>
@@ -1789,11 +1764,11 @@
           <a:p>
             <a:pPr algn="l">
               <a:spcAft>
-                <a:spcPts val="450"/>
+                <a:spcPts val="700"/>
               </a:spcAft>
             </a:pPr>
             <a:r>
-              <a:rPr sz="1150" b="1">
+              <a:rPr sz="1300" b="1">
                 <a:solidFill>
                   <a:srgbClr val="0B4F6C"/>
                 </a:solidFill>
@@ -1802,48 +1777,48 @@
               <a:t>•  Superconducting Circuits: </a:t>
             </a:r>
             <a:r>
-              <a:rPr sz="1150" b="0">
+              <a:rPr sz="1300" b="0">
                 <a:solidFill>
                   <a:srgbClr val="1F2937"/>
                 </a:solidFill>
                 <a:latin typeface="Calibri"/>
               </a:rPr>
-              <a:t>Superconducting circuits are a common implementation of qubits, using Josephson junctions to create a superconducting loop.</a:t>
+              <a:t>Coaxial resonators and Josephson junctions enable qubit control.</a:t>
             </a:r>
           </a:p>
           <a:p>
             <a:pPr algn="l">
               <a:spcAft>
-                <a:spcPts val="450"/>
+                <a:spcPts val="700"/>
               </a:spcAft>
             </a:pPr>
             <a:r>
-              <a:rPr sz="1150" b="1">
+              <a:rPr sz="1300" b="1">
                 <a:solidFill>
                   <a:srgbClr val="0B4F6C"/>
                 </a:solidFill>
                 <a:latin typeface="Calibri"/>
               </a:rPr>
-              <a:t>•  Trapped Ion Architectures: </a:t>
-            </a:r>
-            <a:r>
-              <a:rPr sz="1150" b="0">
+              <a:t>•  Trapped Ion Modalities: </a:t>
+            </a:r>
+            <a:r>
+              <a:rPr sz="1300" b="0">
                 <a:solidFill>
                   <a:srgbClr val="1F2937"/>
                 </a:solidFill>
                 <a:latin typeface="Calibri"/>
               </a:rPr>
-              <a:t>Trapped ion architectures use ions trapped in electromagnetic fields to create a qubit.</a:t>
+              <a:t>Ion trapping and manipulation for precise quantum control.</a:t>
             </a:r>
           </a:p>
           <a:p>
             <a:pPr algn="l">
               <a:spcAft>
-                <a:spcPts val="450"/>
+                <a:spcPts val="700"/>
               </a:spcAft>
             </a:pPr>
             <a:r>
-              <a:rPr sz="1150" b="1">
+              <a:rPr sz="1300" b="1">
                 <a:solidFill>
                   <a:srgbClr val="0B4F6C"/>
                 </a:solidFill>
@@ -1852,38 +1827,13 @@
               <a:t>•  Quantum Dot Implementations: </a:t>
             </a:r>
             <a:r>
-              <a:rPr sz="1150" b="0">
+              <a:rPr sz="1300" b="0">
                 <a:solidFill>
                   <a:srgbClr val="1F2937"/>
                 </a:solidFill>
                 <a:latin typeface="Calibri"/>
               </a:rPr>
-              <a:t>Quantum dot implementations use semiconductor nanocrystals to create a qubit.</a:t>
-            </a:r>
-          </a:p>
-          <a:p>
-            <a:pPr algn="l">
-              <a:spcAft>
-                <a:spcPts val="450"/>
-              </a:spcAft>
-            </a:pPr>
-            <a:r>
-              <a:rPr sz="1150" b="1">
-                <a:solidFill>
-                  <a:srgbClr val="0B4F6C"/>
-                </a:solidFill>
-                <a:latin typeface="Calibri"/>
-              </a:rPr>
-              <a:t>•  Topological Quantum Computing: </a:t>
-            </a:r>
-            <a:r>
-              <a:rPr sz="1150" b="0">
-                <a:solidFill>
-                  <a:srgbClr val="1F2937"/>
-                </a:solidFill>
-                <a:latin typeface="Calibri"/>
-              </a:rPr>
-              <a:t>Topological quantum computing uses exotic materials to create a qubit that is resistant to decoherence.</a:t>
+              <a:t>Quantum confinement and manipulation in semiconductor systems.</a:t>
             </a:r>
           </a:p>
         </p:txBody>
@@ -1938,7 +1888,7 @@
               </a:defRPr>
             </a:pPr>
             <a:r>
-              <a:t>KEY TAKEAWAY: There are various hardware architectures and qubit implementations in quantum computing.</a:t>
+              <a:t>KEY TAKEAWAY: Quantum hardware architectures offer diverse approaches to qubit control and manipulation.</a:t>
             </a:r>
           </a:p>
         </p:txBody>
@@ -2020,7 +1970,7 @@
           <a:lstStyle/>
           <a:p>
             <a:pPr algn="l">
-              <a:defRPr sz="1800" b="1">
+              <a:defRPr sz="2200" b="1">
                 <a:solidFill>
                   <a:srgbClr val="0B4F6C"/>
                 </a:solidFill>
@@ -2028,7 +1978,7 @@
               </a:defRPr>
             </a:pPr>
             <a:r>
-              <a:t>Quantum Algorithms and Computational Speedups</a:t>
+              <a:t>Quantum Algorithms and Speedups</a:t>
             </a:r>
           </a:p>
         </p:txBody>
@@ -2041,8 +1991,8 @@
         </p:nvSpPr>
         <p:spPr>
           <a:xfrm>
-            <a:off x="731520" y="1353312"/>
-            <a:ext cx="7680960" cy="2395728"/>
+            <a:off x="731520" y="1234440"/>
+            <a:ext cx="7680960" cy="2514600"/>
           </a:xfrm>
           <a:prstGeom prst="roundRect">
             <a:avLst/>
@@ -2076,101 +2026,76 @@
           <a:p>
             <a:pPr algn="l">
               <a:spcAft>
-                <a:spcPts val="450"/>
+                <a:spcPts val="700"/>
               </a:spcAft>
             </a:pPr>
             <a:r>
-              <a:rPr sz="1150" b="1">
+              <a:rPr sz="1300" b="1">
                 <a:solidFill>
                   <a:srgbClr val="0B4F6C"/>
                 </a:solidFill>
                 <a:latin typeface="Calibri"/>
               </a:rPr>
-              <a:t>•  Shor's Algorithm: </a:t>
-            </a:r>
-            <a:r>
-              <a:rPr sz="1150" b="0">
+              <a:t>•  Shor's Factoring Algorithm: </a:t>
+            </a:r>
+            <a:r>
+              <a:rPr sz="1300" b="0">
                 <a:solidFill>
                   <a:srgbClr val="1F2937"/>
                 </a:solidFill>
                 <a:latin typeface="Calibri"/>
               </a:rPr>
-              <a:t>Shor's algorithm is a quantum algorithm for factoring large numbers exponentially faster than classical algorithms.</a:t>
+              <a:t>Efficient prime factorization for cryptography and security.</a:t>
             </a:r>
           </a:p>
           <a:p>
             <a:pPr algn="l">
               <a:spcAft>
-                <a:spcPts val="450"/>
+                <a:spcPts val="700"/>
               </a:spcAft>
             </a:pPr>
             <a:r>
-              <a:rPr sz="1150" b="1">
+              <a:rPr sz="1300" b="1">
                 <a:solidFill>
                   <a:srgbClr val="0B4F6C"/>
                 </a:solidFill>
                 <a:latin typeface="Calibri"/>
               </a:rPr>
-              <a:t>•  Grover's Algorithm: </a:t>
-            </a:r>
-            <a:r>
-              <a:rPr sz="1150" b="0">
+              <a:t>•  Grover's Database Search Algorithm: </a:t>
+            </a:r>
+            <a:r>
+              <a:rPr sz="1300" b="0">
                 <a:solidFill>
                   <a:srgbClr val="1F2937"/>
                 </a:solidFill>
                 <a:latin typeface="Calibri"/>
               </a:rPr>
-              <a:t>Grover's algorithm is a quantum algorithm for searching an unsorted database exponentially faster than classical algorithms.</a:t>
+              <a:t>Quadratic speedup for unstructured search problems.</a:t>
             </a:r>
           </a:p>
           <a:p>
             <a:pPr algn="l">
               <a:spcAft>
-                <a:spcPts val="450"/>
+                <a:spcPts val="700"/>
               </a:spcAft>
             </a:pPr>
             <a:r>
-              <a:rPr sz="1150" b="1">
+              <a:rPr sz="1300" b="1">
                 <a:solidFill>
                   <a:srgbClr val="0B4F6C"/>
                 </a:solidFill>
                 <a:latin typeface="Calibri"/>
               </a:rPr>
-              <a:t>•  Quantum Simulation: </a:t>
-            </a:r>
-            <a:r>
-              <a:rPr sz="1150" b="0">
+              <a:t>•  Quantum Parallelism and Interference: </a:t>
+            </a:r>
+            <a:r>
+              <a:rPr sz="1300" b="0">
                 <a:solidFill>
                   <a:srgbClr val="1F2937"/>
                 </a:solidFill>
                 <a:latin typeface="Calibri"/>
               </a:rPr>
-              <a:t>Quantum simulation is a quantum algorithm for simulating complex quantum systems exponentially faster than classical algorithms.</a:t>
-            </a:r>
-          </a:p>
-          <a:p>
-            <a:pPr algn="l">
-              <a:spcAft>
-                <a:spcPts val="450"/>
-              </a:spcAft>
-            </a:pPr>
-            <a:r>
-              <a:rPr sz="1150" b="1">
-                <a:solidFill>
-                  <a:srgbClr val="0B4F6C"/>
-                </a:solidFill>
-                <a:latin typeface="Calibri"/>
-              </a:rPr>
-              <a:t>•  Quantum Optimization: </a:t>
-            </a:r>
-            <a:r>
-              <a:rPr sz="1150" b="0">
-                <a:solidFill>
-                  <a:srgbClr val="1F2937"/>
-                </a:solidFill>
-                <a:latin typeface="Calibri"/>
-              </a:rPr>
-              <a:t>Quantum optimization is a quantum algorithm for solving complex optimization problems exponentially faster than classical algorithms.</a:t>
+              <a:t>Harnessing entanglement for exponential speedup.</a:t>
             </a:r>
           </a:p>
         </p:txBody>
@@ -2225,7 +2150,7 @@
               </a:defRPr>
             </a:pPr>
             <a:r>
-              <a:t>KEY TAKEAWAY: Quantum algorithms can provide significant speedups over classical algorithms for certain problems.</a:t>
+              <a:t>KEY TAKEAWAY: Quantum algorithms offer significant speedup and efficiency advantages over classical computing.</a:t>
             </a:r>
           </a:p>
         </p:txBody>
@@ -2307,7 +2232,7 @@
           <a:lstStyle/>
           <a:p>
             <a:pPr algn="l">
-              <a:defRPr sz="1800" b="1">
+              <a:defRPr sz="2200" b="1">
                 <a:solidFill>
                   <a:srgbClr val="0B4F6C"/>
                 </a:solidFill>
@@ -2315,7 +2240,7 @@
               </a:defRPr>
             </a:pPr>
             <a:r>
-              <a:t>Fault-Tolerant Quantum Computing and Error Correction</a:t>
+              <a:t>Fault-Tolerant Quantum Computing</a:t>
             </a:r>
           </a:p>
         </p:txBody>
@@ -2328,8 +2253,8 @@
         </p:nvSpPr>
         <p:spPr>
           <a:xfrm>
-            <a:off x="731520" y="1353312"/>
-            <a:ext cx="7680960" cy="2395728"/>
+            <a:off x="731520" y="1234440"/>
+            <a:ext cx="7680960" cy="2514600"/>
           </a:xfrm>
           <a:prstGeom prst="roundRect">
             <a:avLst/>
@@ -2363,11 +2288,11 @@
           <a:p>
             <a:pPr algn="l">
               <a:spcAft>
-                <a:spcPts val="450"/>
+                <a:spcPts val="700"/>
               </a:spcAft>
             </a:pPr>
             <a:r>
-              <a:rPr sz="1150" b="1">
+              <a:rPr sz="1300" b="1">
                 <a:solidFill>
                   <a:srgbClr val="0B4F6C"/>
                 </a:solidFill>
@@ -2376,23 +2301,23 @@
               <a:t>•  Surface Code Topologies: </a:t>
             </a:r>
             <a:r>
-              <a:rPr sz="1150" b="0">
+              <a:rPr sz="1300" b="0">
                 <a:solidFill>
                   <a:srgbClr val="1F2937"/>
                 </a:solidFill>
                 <a:latin typeface="Calibri"/>
               </a:rPr>
-              <a:t>Surface code topologies are a method of error correction in quantum computing, using a lattice of qubits to detect and correct errors.</a:t>
+              <a:t>Lattice-based error correction for robust quantum computing.</a:t>
             </a:r>
           </a:p>
           <a:p>
             <a:pPr algn="l">
               <a:spcAft>
-                <a:spcPts val="450"/>
+                <a:spcPts val="700"/>
               </a:spcAft>
             </a:pPr>
             <a:r>
-              <a:rPr sz="1150" b="1">
+              <a:rPr sz="1300" b="1">
                 <a:solidFill>
                   <a:srgbClr val="0B4F6C"/>
                 </a:solidFill>
@@ -2401,63 +2326,38 @@
               <a:t>•  Physical-to-Logical Qubit Overhead: </a:t>
             </a:r>
             <a:r>
-              <a:rPr sz="1150" b="0">
+              <a:rPr sz="1300" b="0">
                 <a:solidFill>
                   <a:srgbClr val="1F2937"/>
                 </a:solidFill>
                 <a:latin typeface="Calibri"/>
               </a:rPr>
-              <a:t>Physical-to-logical qubit overhead is a measure of the number of physical qubits required to implement a logical qubit.</a:t>
+              <a:t>Scaling requirements for reliable quantum computing.</a:t>
             </a:r>
           </a:p>
           <a:p>
             <a:pPr algn="l">
               <a:spcAft>
-                <a:spcPts val="450"/>
+                <a:spcPts val="700"/>
               </a:spcAft>
             </a:pPr>
             <a:r>
-              <a:rPr sz="1150" b="1">
+              <a:rPr sz="1300" b="1">
                 <a:solidFill>
                   <a:srgbClr val="0B4F6C"/>
                 </a:solidFill>
                 <a:latin typeface="Calibri"/>
               </a:rPr>
-              <a:t>•  Error Thresholds: </a:t>
-            </a:r>
-            <a:r>
-              <a:rPr sz="1150" b="0">
+              <a:t>•  Error Thresholds and Correction Codes: </a:t>
+            </a:r>
+            <a:r>
+              <a:rPr sz="1300" b="0">
                 <a:solidFill>
                   <a:srgbClr val="1F2937"/>
                 </a:solidFill>
                 <a:latin typeface="Calibri"/>
               </a:rPr>
-              <a:t>Error thresholds are a measure of the maximum error rate that can be tolerated in a quantum computer before it becomes unreliable.</a:t>
-            </a:r>
-          </a:p>
-          <a:p>
-            <a:pPr algn="l">
-              <a:spcAft>
-                <a:spcPts val="450"/>
-              </a:spcAft>
-            </a:pPr>
-            <a:r>
-              <a:rPr sz="1150" b="1">
-                <a:solidFill>
-                  <a:srgbClr val="0B4F6C"/>
-                </a:solidFill>
-                <a:latin typeface="Calibri"/>
-              </a:rPr>
-              <a:t>•  Quantum Error Correction Codes: </a:t>
-            </a:r>
-            <a:r>
-              <a:rPr sz="1150" b="0">
-                <a:solidFill>
-                  <a:srgbClr val="1F2937"/>
-                </a:solidFill>
-                <a:latin typeface="Calibri"/>
-              </a:rPr>
-              <a:t>Quantum error correction codes are a method of correcting errors in quantum computing, using redundant information to detect and correct errors.</a:t>
+              <a:t>Ensuring reliable quantum computation despite noise and errors.</a:t>
             </a:r>
           </a:p>
         </p:txBody>
@@ -2512,7 +2412,7 @@
               </a:defRPr>
             </a:pPr>
             <a:r>
-              <a:t>KEY TAKEAWAY: Fault-tolerant quantum computing requires robust error correction mechanisms.</a:t>
+              <a:t>KEY TAKEAWAY: Fault-tolerant quantum computing requires robust error correction and scalable architectures.</a:t>
             </a:r>
           </a:p>
         </p:txBody>
@@ -2594,7 +2494,7 @@
           <a:lstStyle/>
           <a:p>
             <a:pPr algn="l">
-              <a:defRPr sz="1800" b="1">
+              <a:defRPr sz="2200" b="1">
                 <a:solidFill>
                   <a:srgbClr val="0B4F6C"/>
                 </a:solidFill>
@@ -2602,7 +2502,7 @@
               </a:defRPr>
             </a:pPr>
             <a:r>
-              <a:t>Practical Enterprise Applications and Industry Use Cases</a:t>
+              <a:t>Enterprise Applications and Use Cases</a:t>
             </a:r>
           </a:p>
         </p:txBody>
@@ -2615,8 +2515,8 @@
         </p:nvSpPr>
         <p:spPr>
           <a:xfrm>
-            <a:off x="731520" y="1353312"/>
-            <a:ext cx="7680960" cy="2395728"/>
+            <a:off x="731520" y="1234440"/>
+            <a:ext cx="7680960" cy="2514600"/>
           </a:xfrm>
           <a:prstGeom prst="roundRect">
             <a:avLst/>
@@ -2650,11 +2550,11 @@
           <a:p>
             <a:pPr algn="l">
               <a:spcAft>
-                <a:spcPts val="450"/>
+                <a:spcPts val="700"/>
               </a:spcAft>
             </a:pPr>
             <a:r>
-              <a:rPr sz="1150" b="1">
+              <a:rPr sz="1300" b="1">
                 <a:solidFill>
                   <a:srgbClr val="0B4F6C"/>
                 </a:solidFill>
@@ -2663,23 +2563,23 @@
               <a:t>•  Post-Quantum Cryptography: </a:t>
             </a:r>
             <a:r>
-              <a:rPr sz="1150" b="0">
+              <a:rPr sz="1300" b="0">
                 <a:solidFill>
                   <a:srgbClr val="1F2937"/>
                 </a:solidFill>
                 <a:latin typeface="Calibri"/>
               </a:rPr>
-              <a:t>Post-quantum cryptography is a method of secure communication that is resistant to quantum attacks.</a:t>
+              <a:t>Secure key exchange and encryption for quantum-resistant cryptography.</a:t>
             </a:r>
           </a:p>
           <a:p>
             <a:pPr algn="l">
               <a:spcAft>
-                <a:spcPts val="450"/>
+                <a:spcPts val="700"/>
               </a:spcAft>
             </a:pPr>
             <a:r>
-              <a:rPr sz="1150" b="1">
+              <a:rPr sz="1300" b="1">
                 <a:solidFill>
                   <a:srgbClr val="0B4F6C"/>
                 </a:solidFill>
@@ -2688,63 +2588,38 @@
               <a:t>•  Financial Portfolio Optimization: </a:t>
             </a:r>
             <a:r>
-              <a:rPr sz="1150" b="0">
+              <a:rPr sz="1300" b="0">
                 <a:solidFill>
                   <a:srgbClr val="1F2937"/>
                 </a:solidFill>
                 <a:latin typeface="Calibri"/>
               </a:rPr>
-              <a:t>Financial portfolio optimization is a method of optimizing investment portfolios using quantum computing.</a:t>
+              <a:t>Quantum speedup for complex financial modeling and optimization.</a:t>
             </a:r>
           </a:p>
           <a:p>
             <a:pPr algn="l">
               <a:spcAft>
-                <a:spcPts val="450"/>
+                <a:spcPts val="700"/>
               </a:spcAft>
             </a:pPr>
             <a:r>
-              <a:rPr sz="1150" b="1">
+              <a:rPr sz="1300" b="1">
                 <a:solidFill>
                   <a:srgbClr val="0B4F6C"/>
                 </a:solidFill>
                 <a:latin typeface="Calibri"/>
               </a:rPr>
-              <a:t>•  Materials Science Simulation: </a:t>
-            </a:r>
-            <a:r>
-              <a:rPr sz="1150" b="0">
+              <a:t>•  Material Simulation and Chemistry: </a:t>
+            </a:r>
+            <a:r>
+              <a:rPr sz="1300" b="0">
                 <a:solidFill>
                   <a:srgbClr val="1F2937"/>
                 </a:solidFill>
                 <a:latin typeface="Calibri"/>
               </a:rPr>
-              <a:t>Materials science simulation is a method of simulating the properties of materials using quantum computing.</a:t>
-            </a:r>
-          </a:p>
-          <a:p>
-            <a:pPr algn="l">
-              <a:spcAft>
-                <a:spcPts val="450"/>
-              </a:spcAft>
-            </a:pPr>
-            <a:r>
-              <a:rPr sz="1150" b="1">
-                <a:solidFill>
-                  <a:srgbClr val="0B4F6C"/>
-                </a:solidFill>
-                <a:latin typeface="Calibri"/>
-              </a:rPr>
-              <a:t>•  Logistics Optimization: </a:t>
-            </a:r>
-            <a:r>
-              <a:rPr sz="1150" b="0">
-                <a:solidFill>
-                  <a:srgbClr val="1F2937"/>
-                </a:solidFill>
-                <a:latin typeface="Calibri"/>
-              </a:rPr>
-              <a:t>Logistics optimization is a method of optimizing supply chain management using quantum computing.</a:t>
+              <a:t>Quantum simulation for materials science and chemical discovery.</a:t>
             </a:r>
           </a:p>
         </p:txBody>
@@ -2799,7 +2674,7 @@
               </a:defRPr>
             </a:pPr>
             <a:r>
-              <a:t>KEY TAKEAWAY: Quantum computing has practical applications in various industries.</a:t>
+              <a:t>KEY TAKEAWAY: Quantum computing offers significant opportunities for enterprise applications and use cases.</a:t>
             </a:r>
           </a:p>
         </p:txBody>
@@ -2853,7 +2728,7 @@
               </a:defRPr>
             </a:pPr>
             <a:r>
-              <a:t>BENCHMARKS &amp; METRICS</a:t>
+              <a:t>OPERATIONAL BENCHMARKS</a:t>
             </a:r>
           </a:p>
         </p:txBody>
@@ -2881,7 +2756,7 @@
           <a:lstStyle/>
           <a:p>
             <a:pPr algn="l">
-              <a:defRPr sz="1800" b="1">
+              <a:defRPr sz="2200" b="1">
                 <a:solidFill>
                   <a:srgbClr val="0B4F6C"/>
                 </a:solidFill>
@@ -2889,7 +2764,7 @@
               </a:defRPr>
             </a:pPr>
             <a:r>
-              <a:t>Operational Benchmarks and Quantum Volume Metrics</a:t>
+              <a:t>Operational Benchmarks and Roadmap</a:t>
             </a:r>
           </a:p>
         </p:txBody>
@@ -2902,8 +2777,8 @@
         </p:nvSpPr>
         <p:spPr>
           <a:xfrm>
-            <a:off x="731520" y="1353312"/>
-            <a:ext cx="7680960" cy="2395728"/>
+            <a:off x="731520" y="1234440"/>
+            <a:ext cx="7680960" cy="2514600"/>
           </a:xfrm>
           <a:prstGeom prst="roundRect">
             <a:avLst/>
@@ -2937,101 +2812,76 @@
           <a:p>
             <a:pPr algn="l">
               <a:spcAft>
-                <a:spcPts val="450"/>
+                <a:spcPts val="700"/>
               </a:spcAft>
             </a:pPr>
             <a:r>
-              <a:rPr sz="1150" b="1">
+              <a:rPr sz="1300" b="1">
                 <a:solidFill>
                   <a:srgbClr val="0B4F6C"/>
                 </a:solidFill>
                 <a:latin typeface="Calibri"/>
               </a:rPr>
-              <a:t>•  Quantum Volume: </a:t>
-            </a:r>
-            <a:r>
-              <a:rPr sz="1150" b="0">
+              <a:t>•  Quantum Volume Metrics: </a:t>
+            </a:r>
+            <a:r>
+              <a:rPr sz="1300" b="0">
                 <a:solidFill>
                   <a:srgbClr val="1F2937"/>
                 </a:solidFill>
                 <a:latin typeface="Calibri"/>
               </a:rPr>
-              <a:t>Quantum volume is a measure of the computational power of a quantum computer, using the number of qubits and the number of cycles.</a:t>
+              <a:t>Evaluating the performance and scalability of quantum computers.</a:t>
             </a:r>
           </a:p>
           <a:p>
             <a:pPr algn="l">
               <a:spcAft>
-                <a:spcPts val="450"/>
+                <a:spcPts val="700"/>
               </a:spcAft>
             </a:pPr>
             <a:r>
-              <a:rPr sz="1150" b="1">
+              <a:rPr sz="1300" b="1">
                 <a:solidFill>
                   <a:srgbClr val="0B4F6C"/>
                 </a:solidFill>
                 <a:latin typeface="Calibri"/>
               </a:rPr>
-              <a:t>•  Operational Benchmarks: </a:t>
-            </a:r>
-            <a:r>
-              <a:rPr sz="1150" b="0">
+              <a:t>•  Hardware Roadmap Timeline: </a:t>
+            </a:r>
+            <a:r>
+              <a:rPr sz="1300" b="0">
                 <a:solidFill>
                   <a:srgbClr val="1F2937"/>
                 </a:solidFill>
                 <a:latin typeface="Calibri"/>
               </a:rPr>
-              <a:t>Operational benchmarks are a measure of the performance of a quantum computer, using metrics such as error rates and fidelity.</a:t>
+              <a:t>Projected advancements in quantum computing hardware and technology.</a:t>
             </a:r>
           </a:p>
           <a:p>
             <a:pPr algn="l">
               <a:spcAft>
-                <a:spcPts val="450"/>
+                <a:spcPts val="700"/>
               </a:spcAft>
             </a:pPr>
             <a:r>
-              <a:rPr sz="1150" b="1">
+              <a:rPr sz="1300" b="1">
                 <a:solidFill>
                   <a:srgbClr val="0B4F6C"/>
                 </a:solidFill>
                 <a:latin typeface="Calibri"/>
               </a:rPr>
-              <a:t>•  Hardware Roadmap: </a:t>
-            </a:r>
-            <a:r>
-              <a:rPr sz="1150" b="0">
+              <a:t>•  Operational Performance and Scalability: </a:t>
+            </a:r>
+            <a:r>
+              <a:rPr sz="1300" b="0">
                 <a:solidFill>
                   <a:srgbClr val="1F2937"/>
                 </a:solidFill>
                 <a:latin typeface="Calibri"/>
               </a:rPr>
-              <a:t>The hardware roadmap is a plan for the development and deployment of quantum computers, including timelines and milestones.</a:t>
-            </a:r>
-          </a:p>
-          <a:p>
-            <a:pPr algn="l">
-              <a:spcAft>
-                <a:spcPts val="450"/>
-              </a:spcAft>
-            </a:pPr>
-            <a:r>
-              <a:rPr sz="1150" b="1">
-                <a:solidFill>
-                  <a:srgbClr val="0B4F6C"/>
-                </a:solidFill>
-                <a:latin typeface="Calibri"/>
-              </a:rPr>
-              <a:t>•  Performance Metrics: </a:t>
-            </a:r>
-            <a:r>
-              <a:rPr sz="1150" b="0">
-                <a:solidFill>
-                  <a:srgbClr val="1F2937"/>
-                </a:solidFill>
-                <a:latin typeface="Calibri"/>
-              </a:rPr>
-              <a:t>Performance metrics are a measure of the performance of a quantum computer, using metrics such as quantum volume and operational benchmarks.</a:t>
+              <a:t>Achieving reliable and efficient quantum computing at scale.</a:t>
             </a:r>
           </a:p>
         </p:txBody>
@@ -3086,7 +2936,7 @@
               </a:defRPr>
             </a:pPr>
             <a:r>
-              <a:t>KEY TAKEAWAY: Quantum computing has operational benchmarks and metrics to measure its performance.</a:t>
+              <a:t>KEY TAKEAWAY: Quantum computing requires rigorous operational benchmarks and a clear roadmap for advancement.</a:t>
             </a:r>
           </a:p>
         </p:txBody>
@@ -3140,7 +2990,7 @@
               </a:defRPr>
             </a:pPr>
             <a:r>
-              <a:t>STRATEGIC ROADMAP</a:t>
+              <a:t>STRATEGIC GOVERNANCE</a:t>
             </a:r>
           </a:p>
         </p:txBody>
@@ -3168,7 +3018,7 @@
           <a:lstStyle/>
           <a:p>
             <a:pPr algn="l">
-              <a:defRPr sz="1800" b="1">
+              <a:defRPr sz="2200" b="1">
                 <a:solidFill>
                   <a:srgbClr val="0B4F6C"/>
                 </a:solidFill>
@@ -3176,7 +3026,7 @@
               </a:defRPr>
             </a:pPr>
             <a:r>
-              <a:t>Strategic Recommendations and Enterprise Action Plan</a:t>
+              <a:t>Strategic Recommendations and Governance</a:t>
             </a:r>
           </a:p>
         </p:txBody>
@@ -3189,8 +3039,8 @@
         </p:nvSpPr>
         <p:spPr>
           <a:xfrm>
-            <a:off x="731520" y="1353312"/>
-            <a:ext cx="7680960" cy="2395728"/>
+            <a:off x="731520" y="1234440"/>
+            <a:ext cx="7680960" cy="2514600"/>
           </a:xfrm>
           <a:prstGeom prst="roundRect">
             <a:avLst/>
@@ -3224,101 +3074,76 @@
           <a:p>
             <a:pPr algn="l">
               <a:spcAft>
-                <a:spcPts val="450"/>
+                <a:spcPts val="700"/>
               </a:spcAft>
             </a:pPr>
             <a:r>
-              <a:rPr sz="1150" b="1">
+              <a:rPr sz="1300" b="1">
                 <a:solidFill>
                   <a:srgbClr val="0B4F6C"/>
                 </a:solidFill>
                 <a:latin typeface="Calibri"/>
               </a:rPr>
-              <a:t>•  Quantum Computing Governance: </a:t>
-            </a:r>
-            <a:r>
-              <a:rPr sz="1150" b="0">
+              <a:t>•  Quantum Computing Governance and Risk Management: </a:t>
+            </a:r>
+            <a:r>
+              <a:rPr sz="1300" b="0">
                 <a:solidFill>
                   <a:srgbClr val="1F2937"/>
                 </a:solidFill>
                 <a:latin typeface="Calibri"/>
               </a:rPr>
-              <a:t>Quantum computing governance is a framework for managing the development and deployment of quantum computers, including risk management and security.</a:t>
+              <a:t>Ensuring responsible and secure quantum computing adoption.</a:t>
             </a:r>
           </a:p>
           <a:p>
             <a:pPr algn="l">
               <a:spcAft>
-                <a:spcPts val="450"/>
+                <a:spcPts val="700"/>
               </a:spcAft>
             </a:pPr>
             <a:r>
-              <a:rPr sz="1150" b="1">
+              <a:rPr sz="1300" b="1">
                 <a:solidFill>
                   <a:srgbClr val="0B4F6C"/>
                 </a:solidFill>
                 <a:latin typeface="Calibri"/>
               </a:rPr>
-              <a:t>•  Immediate Action Plan: </a:t>
-            </a:r>
-            <a:r>
-              <a:rPr sz="1150" b="0">
+              <a:t>•  Strategic Planning and Resource Allocation: </a:t>
+            </a:r>
+            <a:r>
+              <a:rPr sz="1300" b="0">
                 <a:solidFill>
                   <a:srgbClr val="1F2937"/>
                 </a:solidFill>
                 <a:latin typeface="Calibri"/>
               </a:rPr>
-              <a:t>The immediate action plan is a plan for the short-term development and deployment of quantum computers, including timelines and milestones.</a:t>
+              <a:t>Prioritizing quantum computing investments and resource allocation.</a:t>
             </a:r>
           </a:p>
           <a:p>
             <a:pPr algn="l">
               <a:spcAft>
-                <a:spcPts val="450"/>
+                <a:spcPts val="700"/>
               </a:spcAft>
             </a:pPr>
             <a:r>
-              <a:rPr sz="1150" b="1">
+              <a:rPr sz="1300" b="1">
                 <a:solidFill>
                   <a:srgbClr val="0B4F6C"/>
                 </a:solidFill>
                 <a:latin typeface="Calibri"/>
               </a:rPr>
-              <a:t>•  Key Performance Indicators: </a:t>
-            </a:r>
-            <a:r>
-              <a:rPr sz="1150" b="0">
+              <a:t>•  Immediate Enterprise Action Plan: </a:t>
+            </a:r>
+            <a:r>
+              <a:rPr sz="1300" b="0">
                 <a:solidFill>
                   <a:srgbClr val="1F2937"/>
                 </a:solidFill>
                 <a:latin typeface="Calibri"/>
               </a:rPr>
-              <a:t>Key performance indicators are a measure of the performance of a quantum computer, using metrics such as quantum volume and operational benchmarks.</a:t>
-            </a:r>
-          </a:p>
-          <a:p>
-            <a:pPr algn="l">
-              <a:spcAft>
-                <a:spcPts val="450"/>
-              </a:spcAft>
-            </a:pPr>
-            <a:r>
-              <a:rPr sz="1150" b="1">
-                <a:solidFill>
-                  <a:srgbClr val="0B4F6C"/>
-                </a:solidFill>
-                <a:latin typeface="Calibri"/>
-              </a:rPr>
-              <a:t>•  Risk Management: </a:t>
-            </a:r>
-            <a:r>
-              <a:rPr sz="1150" b="0">
-                <a:solidFill>
-                  <a:srgbClr val="1F2937"/>
-                </a:solidFill>
-                <a:latin typeface="Calibri"/>
-              </a:rPr>
-              <a:t>Risk management is a framework for managing the risks associated with quantum computing, including security and regulatory risks.</a:t>
+              <a:t>Developing a clear plan for quantum computing adoption and integration.</a:t>
             </a:r>
           </a:p>
         </p:txBody>
@@ -3373,7 +3198,7 @@
               </a:defRPr>
             </a:pPr>
             <a:r>
-              <a:t>KEY TAKEAWAY: A strategic plan is necessary for the development and deployment of quantum computers.</a:t>
+              <a:t>KEY TAKEAWAY: Effective governance and strategic planning are critical for successful quantum computing adoption.</a:t>
             </a:r>
           </a:p>
         </p:txBody>

</xml_diff>